<commit_message>
Rebuild Team Contribution slide with a simpler shape pattern
PowerPoint flagged the deck for repair on open and silently dropped the
Team Contribution slide, even though it passed full OOXML schema/
relationship/content-type validation. Rebuilt that slide using the same
ellipse+text pattern already proven safe on the Business Questions
slides, instead of the roundRect card background it used before.
</commit_message>
<xml_diff>
--- a/deliverables/Mini_Project_Olist_DW.pptx
+++ b/deliverables/Mini_Project_Olist_DW.pptx
@@ -2921,19 +2921,17 @@
         <p:spPr>
           <a:xfrm>
             <a:off x="640080" y="1600200"/>
-            <a:ext cx="10881360" cy="868680"/>
-          </a:xfrm>
-          <a:prstGeom prst="roundRect">
-            <a:avLst>
-              <a:gd name="adj" fmla="val 6316"/>
-            </a:avLst>
+            <a:ext cx="365760" cy="365760"/>
+          </a:xfrm>
+          <a:prstGeom prst="ellipse">
+            <a:avLst/>
           </a:prstGeom>
           <a:solidFill>
-            <a:srgbClr val="F4F7F9"/>
+            <a:srgbClr val="1C7293"/>
           </a:solidFill>
           <a:ln w="12700">
             <a:solidFill>
-              <a:srgbClr val="E1E7EC"/>
+              <a:srgbClr val="333333"/>
             </a:solidFill>
             <a:prstDash val="solid"/>
           </a:ln>
@@ -2947,8 +2945,47 @@
         </p:nvSpPr>
         <p:spPr>
           <a:xfrm>
-            <a:off x="914400" y="1691640"/>
-            <a:ext cx="3291840" cy="365760"/>
+            <a:off x="640080" y="1600200"/>
+            <a:ext cx="365760" cy="365760"/>
+          </a:xfrm>
+          <a:prstGeom prst="rect">
+            <a:avLst/>
+          </a:prstGeom>
+          <a:noFill/>
+          <a:ln/>
+        </p:spPr>
+        <p:txBody>
+          <a:bodyPr wrap="square" lIns="0" tIns="0" rIns="0" bIns="0" rtlCol="0" anchor="ctr"/>
+          <a:lstStyle/>
+          <a:p>
+            <a:pPr algn="ctr" indent="0" marL="0">
+              <a:buNone/>
+            </a:pPr>
+            <a:r>
+              <a:rPr lang="en-US" sz="1400" b="1" dirty="0">
+                <a:solidFill>
+                  <a:srgbClr val="FFFFFF"/>
+                </a:solidFill>
+                <a:latin typeface="Calibri" pitchFamily="34" charset="0"/>
+                <a:ea typeface="Calibri" pitchFamily="34" charset="-122"/>
+                <a:cs typeface="Calibri" pitchFamily="34" charset="-120"/>
+              </a:rPr>
+              <a:t>1</a:t>
+            </a:r>
+            <a:endParaRPr lang="en-US" sz="1400" dirty="0"/>
+          </a:p>
+        </p:txBody>
+      </p:sp>
+      <p:sp>
+        <p:nvSpPr>
+          <p:cNvPr id="5" name="Text 3"/>
+          <p:cNvSpPr txBox="1"/>
+          <p:nvPr/>
+        </p:nvSpPr>
+        <p:spPr>
+          <a:xfrm>
+            <a:off x="1188720" y="1554480"/>
+            <a:ext cx="9966960" cy="365760"/>
           </a:xfrm>
           <a:prstGeom prst="rect">
             <a:avLst/>
@@ -2964,7 +3001,7 @@
               <a:buNone/>
             </a:pPr>
             <a:r>
-              <a:rPr lang="en-US" sz="1400" b="1" dirty="0">
+              <a:rPr lang="en-US" sz="1500" b="1" dirty="0">
                 <a:solidFill>
                   <a:srgbClr val="1B1F2A"/>
                 </a:solidFill>
@@ -2972,22 +3009,22 @@
                 <a:ea typeface="Calibri" pitchFamily="34" charset="-122"/>
                 <a:cs typeface="Calibri" pitchFamily="34" charset="-120"/>
               </a:rPr>
-              <a:t>ชวนากร เพชรเจริญรัตน์</a:t>
-            </a:r>
-            <a:endParaRPr lang="en-US" sz="1400" dirty="0"/>
-          </a:p>
-        </p:txBody>
-      </p:sp>
-      <p:sp>
-        <p:nvSpPr>
-          <p:cNvPr id="5" name="Text 3"/>
-          <p:cNvSpPr txBox="1"/>
-          <p:nvPr/>
-        </p:nvSpPr>
-        <p:spPr>
-          <a:xfrm>
-            <a:off x="914400" y="2057400"/>
-            <a:ext cx="3291840" cy="320040"/>
+              <a:t>ชวนากร เพชรเจริญรัตน์  (@chawanakorn-phet)</a:t>
+            </a:r>
+            <a:endParaRPr lang="en-US" sz="1500" dirty="0"/>
+          </a:p>
+        </p:txBody>
+      </p:sp>
+      <p:sp>
+        <p:nvSpPr>
+          <p:cNvPr id="6" name="Text 4"/>
+          <p:cNvSpPr txBox="1"/>
+          <p:nvPr/>
+        </p:nvSpPr>
+        <p:spPr>
+          <a:xfrm>
+            <a:off x="1188720" y="1920240"/>
+            <a:ext cx="9966960" cy="365760"/>
           </a:xfrm>
           <a:prstGeom prst="rect">
             <a:avLst/>
@@ -3003,46 +3040,7 @@
               <a:buNone/>
             </a:pPr>
             <a:r>
-              <a:rPr lang="en-US" sz="1100" dirty="0">
-                <a:solidFill>
-                  <a:srgbClr val="5B6472"/>
-                </a:solidFill>
-                <a:latin typeface="Calibri" pitchFamily="34" charset="0"/>
-                <a:ea typeface="Calibri" pitchFamily="34" charset="-122"/>
-                <a:cs typeface="Calibri" pitchFamily="34" charset="-120"/>
-              </a:rPr>
-              <a:t>@chawanakorn-phet</a:t>
-            </a:r>
-            <a:endParaRPr lang="en-US" sz="1100" dirty="0"/>
-          </a:p>
-        </p:txBody>
-      </p:sp>
-      <p:sp>
-        <p:nvSpPr>
-          <p:cNvPr id="6" name="Text 4"/>
-          <p:cNvSpPr txBox="1"/>
-          <p:nvPr/>
-        </p:nvSpPr>
-        <p:spPr>
-          <a:xfrm>
-            <a:off x="4389120" y="1847088"/>
-            <a:ext cx="6858000" cy="365760"/>
-          </a:xfrm>
-          <a:prstGeom prst="rect">
-            <a:avLst/>
-          </a:prstGeom>
-          <a:noFill/>
-          <a:ln/>
-        </p:spPr>
-        <p:txBody>
-          <a:bodyPr wrap="square" lIns="0" tIns="0" rIns="0" bIns="0" rtlCol="0" anchor="ctr"/>
-          <a:lstStyle/>
-          <a:p>
-            <a:pPr indent="0" marL="0">
-              <a:buNone/>
-            </a:pPr>
-            <a:r>
-              <a:rPr lang="en-US" sz="1250" dirty="0">
+              <a:rPr lang="en-US" sz="1300" dirty="0">
                 <a:solidFill>
                   <a:srgbClr val="1C7293"/>
                 </a:solidFill>
@@ -3052,7 +3050,7 @@
               </a:rPr>
               <a:t>Data Modeling, dbt Pipeline, Dashboard</a:t>
             </a:r>
-            <a:endParaRPr lang="en-US" sz="1250" dirty="0"/>
+            <a:endParaRPr lang="en-US" sz="1300" dirty="0"/>
           </a:p>
         </p:txBody>
       </p:sp>
@@ -3064,20 +3062,18 @@
         </p:nvSpPr>
         <p:spPr>
           <a:xfrm>
-            <a:off x="640080" y="2606040"/>
-            <a:ext cx="10881360" cy="868680"/>
-          </a:xfrm>
-          <a:prstGeom prst="roundRect">
-            <a:avLst>
-              <a:gd name="adj" fmla="val 6316"/>
-            </a:avLst>
+            <a:off x="640080" y="2560320"/>
+            <a:ext cx="365760" cy="365760"/>
+          </a:xfrm>
+          <a:prstGeom prst="ellipse">
+            <a:avLst/>
           </a:prstGeom>
           <a:solidFill>
-            <a:srgbClr val="F4F7F9"/>
+            <a:srgbClr val="1C7293"/>
           </a:solidFill>
           <a:ln w="12700">
             <a:solidFill>
-              <a:srgbClr val="E1E7EC"/>
+              <a:srgbClr val="333333"/>
             </a:solidFill>
             <a:prstDash val="solid"/>
           </a:ln>
@@ -3091,8 +3087,47 @@
         </p:nvSpPr>
         <p:spPr>
           <a:xfrm>
-            <a:off x="914400" y="2697480"/>
-            <a:ext cx="3291840" cy="365760"/>
+            <a:off x="640080" y="2560320"/>
+            <a:ext cx="365760" cy="365760"/>
+          </a:xfrm>
+          <a:prstGeom prst="rect">
+            <a:avLst/>
+          </a:prstGeom>
+          <a:noFill/>
+          <a:ln/>
+        </p:spPr>
+        <p:txBody>
+          <a:bodyPr wrap="square" lIns="0" tIns="0" rIns="0" bIns="0" rtlCol="0" anchor="ctr"/>
+          <a:lstStyle/>
+          <a:p>
+            <a:pPr algn="ctr" indent="0" marL="0">
+              <a:buNone/>
+            </a:pPr>
+            <a:r>
+              <a:rPr lang="en-US" sz="1400" b="1" dirty="0">
+                <a:solidFill>
+                  <a:srgbClr val="FFFFFF"/>
+                </a:solidFill>
+                <a:latin typeface="Calibri" pitchFamily="34" charset="0"/>
+                <a:ea typeface="Calibri" pitchFamily="34" charset="-122"/>
+                <a:cs typeface="Calibri" pitchFamily="34" charset="-120"/>
+              </a:rPr>
+              <a:t>2</a:t>
+            </a:r>
+            <a:endParaRPr lang="en-US" sz="1400" dirty="0"/>
+          </a:p>
+        </p:txBody>
+      </p:sp>
+      <p:sp>
+        <p:nvSpPr>
+          <p:cNvPr id="9" name="Text 7"/>
+          <p:cNvSpPr txBox="1"/>
+          <p:nvPr/>
+        </p:nvSpPr>
+        <p:spPr>
+          <a:xfrm>
+            <a:off x="1188720" y="2514600"/>
+            <a:ext cx="9966960" cy="365760"/>
           </a:xfrm>
           <a:prstGeom prst="rect">
             <a:avLst/>
@@ -3108,7 +3143,7 @@
               <a:buNone/>
             </a:pPr>
             <a:r>
-              <a:rPr lang="en-US" sz="1400" b="1" dirty="0">
+              <a:rPr lang="en-US" sz="1500" b="1" dirty="0">
                 <a:solidFill>
                   <a:srgbClr val="1B1F2A"/>
                 </a:solidFill>
@@ -3116,22 +3151,22 @@
                 <a:ea typeface="Calibri" pitchFamily="34" charset="-122"/>
                 <a:cs typeface="Calibri" pitchFamily="34" charset="-120"/>
               </a:rPr>
-              <a:t>กุลธิดา สมาขันธ์</a:t>
-            </a:r>
-            <a:endParaRPr lang="en-US" sz="1400" dirty="0"/>
-          </a:p>
-        </p:txBody>
-      </p:sp>
-      <p:sp>
-        <p:nvSpPr>
-          <p:cNvPr id="9" name="Text 7"/>
-          <p:cNvSpPr txBox="1"/>
-          <p:nvPr/>
-        </p:nvSpPr>
-        <p:spPr>
-          <a:xfrm>
-            <a:off x="914400" y="3063240"/>
-            <a:ext cx="3291840" cy="320040"/>
+              <a:t>กุลธิดา สมาขันธ์  (@kunthida-samakhan)</a:t>
+            </a:r>
+            <a:endParaRPr lang="en-US" sz="1500" dirty="0"/>
+          </a:p>
+        </p:txBody>
+      </p:sp>
+      <p:sp>
+        <p:nvSpPr>
+          <p:cNvPr id="10" name="Text 8"/>
+          <p:cNvSpPr txBox="1"/>
+          <p:nvPr/>
+        </p:nvSpPr>
+        <p:spPr>
+          <a:xfrm>
+            <a:off x="1188720" y="2880360"/>
+            <a:ext cx="9966960" cy="365760"/>
           </a:xfrm>
           <a:prstGeom prst="rect">
             <a:avLst/>
@@ -3147,46 +3182,7 @@
               <a:buNone/>
             </a:pPr>
             <a:r>
-              <a:rPr lang="en-US" sz="1100" dirty="0">
-                <a:solidFill>
-                  <a:srgbClr val="5B6472"/>
-                </a:solidFill>
-                <a:latin typeface="Calibri" pitchFamily="34" charset="0"/>
-                <a:ea typeface="Calibri" pitchFamily="34" charset="-122"/>
-                <a:cs typeface="Calibri" pitchFamily="34" charset="-120"/>
-              </a:rPr>
-              <a:t>@kunthida-samakhan</a:t>
-            </a:r>
-            <a:endParaRPr lang="en-US" sz="1100" dirty="0"/>
-          </a:p>
-        </p:txBody>
-      </p:sp>
-      <p:sp>
-        <p:nvSpPr>
-          <p:cNvPr id="10" name="Text 8"/>
-          <p:cNvSpPr txBox="1"/>
-          <p:nvPr/>
-        </p:nvSpPr>
-        <p:spPr>
-          <a:xfrm>
-            <a:off x="4389120" y="2852928"/>
-            <a:ext cx="6858000" cy="365760"/>
-          </a:xfrm>
-          <a:prstGeom prst="rect">
-            <a:avLst/>
-          </a:prstGeom>
-          <a:noFill/>
-          <a:ln/>
-        </p:spPr>
-        <p:txBody>
-          <a:bodyPr wrap="square" lIns="0" tIns="0" rIns="0" bIns="0" rtlCol="0" anchor="ctr"/>
-          <a:lstStyle/>
-          <a:p>
-            <a:pPr indent="0" marL="0">
-              <a:buNone/>
-            </a:pPr>
-            <a:r>
-              <a:rPr lang="en-US" sz="1250" dirty="0">
+              <a:rPr lang="en-US" sz="1300" dirty="0">
                 <a:solidFill>
                   <a:srgbClr val="1C7293"/>
                 </a:solidFill>
@@ -3196,7 +3192,7 @@
               </a:rPr>
               <a:t>Business Questions, Infographic</a:t>
             </a:r>
-            <a:endParaRPr lang="en-US" sz="1250" dirty="0"/>
+            <a:endParaRPr lang="en-US" sz="1300" dirty="0"/>
           </a:p>
         </p:txBody>
       </p:sp>
@@ -3208,20 +3204,18 @@
         </p:nvSpPr>
         <p:spPr>
           <a:xfrm>
-            <a:off x="640080" y="3611880"/>
-            <a:ext cx="10881360" cy="868680"/>
-          </a:xfrm>
-          <a:prstGeom prst="roundRect">
-            <a:avLst>
-              <a:gd name="adj" fmla="val 6316"/>
-            </a:avLst>
+            <a:off x="640080" y="3520440"/>
+            <a:ext cx="365760" cy="365760"/>
+          </a:xfrm>
+          <a:prstGeom prst="ellipse">
+            <a:avLst/>
           </a:prstGeom>
           <a:solidFill>
-            <a:srgbClr val="F4F7F9"/>
+            <a:srgbClr val="1C7293"/>
           </a:solidFill>
           <a:ln w="12700">
             <a:solidFill>
-              <a:srgbClr val="E1E7EC"/>
+              <a:srgbClr val="333333"/>
             </a:solidFill>
             <a:prstDash val="solid"/>
           </a:ln>
@@ -3235,8 +3229,47 @@
         </p:nvSpPr>
         <p:spPr>
           <a:xfrm>
-            <a:off x="914400" y="3703320"/>
-            <a:ext cx="3291840" cy="365760"/>
+            <a:off x="640080" y="3520440"/>
+            <a:ext cx="365760" cy="365760"/>
+          </a:xfrm>
+          <a:prstGeom prst="rect">
+            <a:avLst/>
+          </a:prstGeom>
+          <a:noFill/>
+          <a:ln/>
+        </p:spPr>
+        <p:txBody>
+          <a:bodyPr wrap="square" lIns="0" tIns="0" rIns="0" bIns="0" rtlCol="0" anchor="ctr"/>
+          <a:lstStyle/>
+          <a:p>
+            <a:pPr algn="ctr" indent="0" marL="0">
+              <a:buNone/>
+            </a:pPr>
+            <a:r>
+              <a:rPr lang="en-US" sz="1400" b="1" dirty="0">
+                <a:solidFill>
+                  <a:srgbClr val="FFFFFF"/>
+                </a:solidFill>
+                <a:latin typeface="Calibri" pitchFamily="34" charset="0"/>
+                <a:ea typeface="Calibri" pitchFamily="34" charset="-122"/>
+                <a:cs typeface="Calibri" pitchFamily="34" charset="-120"/>
+              </a:rPr>
+              <a:t>3</a:t>
+            </a:r>
+            <a:endParaRPr lang="en-US" sz="1400" dirty="0"/>
+          </a:p>
+        </p:txBody>
+      </p:sp>
+      <p:sp>
+        <p:nvSpPr>
+          <p:cNvPr id="13" name="Text 11"/>
+          <p:cNvSpPr txBox="1"/>
+          <p:nvPr/>
+        </p:nvSpPr>
+        <p:spPr>
+          <a:xfrm>
+            <a:off x="1188720" y="3474720"/>
+            <a:ext cx="9966960" cy="365760"/>
           </a:xfrm>
           <a:prstGeom prst="rect">
             <a:avLst/>
@@ -3252,7 +3285,7 @@
               <a:buNone/>
             </a:pPr>
             <a:r>
-              <a:rPr lang="en-US" sz="1400" b="1" dirty="0">
+              <a:rPr lang="en-US" sz="1500" b="1" dirty="0">
                 <a:solidFill>
                   <a:srgbClr val="1B1F2A"/>
                 </a:solidFill>
@@ -3260,22 +3293,22 @@
                 <a:ea typeface="Calibri" pitchFamily="34" charset="-122"/>
                 <a:cs typeface="Calibri" pitchFamily="34" charset="-120"/>
               </a:rPr>
-              <a:t>วรวัฒน์ พรหมคุณ</a:t>
-            </a:r>
-            <a:endParaRPr lang="en-US" sz="1400" dirty="0"/>
-          </a:p>
-        </p:txBody>
-      </p:sp>
-      <p:sp>
-        <p:nvSpPr>
-          <p:cNvPr id="13" name="Text 11"/>
-          <p:cNvSpPr txBox="1"/>
-          <p:nvPr/>
-        </p:nvSpPr>
-        <p:spPr>
-          <a:xfrm>
-            <a:off x="914400" y="4069080"/>
-            <a:ext cx="3291840" cy="320040"/>
+              <a:t>วรวัฒน์ พรหมคุณ  (@worawatpr-gh)</a:t>
+            </a:r>
+            <a:endParaRPr lang="en-US" sz="1500" dirty="0"/>
+          </a:p>
+        </p:txBody>
+      </p:sp>
+      <p:sp>
+        <p:nvSpPr>
+          <p:cNvPr id="14" name="Text 12"/>
+          <p:cNvSpPr txBox="1"/>
+          <p:nvPr/>
+        </p:nvSpPr>
+        <p:spPr>
+          <a:xfrm>
+            <a:off x="1188720" y="3840480"/>
+            <a:ext cx="9966960" cy="365760"/>
           </a:xfrm>
           <a:prstGeom prst="rect">
             <a:avLst/>
@@ -3291,46 +3324,7 @@
               <a:buNone/>
             </a:pPr>
             <a:r>
-              <a:rPr lang="en-US" sz="1100" dirty="0">
-                <a:solidFill>
-                  <a:srgbClr val="5B6472"/>
-                </a:solidFill>
-                <a:latin typeface="Calibri" pitchFamily="34" charset="0"/>
-                <a:ea typeface="Calibri" pitchFamily="34" charset="-122"/>
-                <a:cs typeface="Calibri" pitchFamily="34" charset="-120"/>
-              </a:rPr>
-              <a:t>@worawatpr-gh</a:t>
-            </a:r>
-            <a:endParaRPr lang="en-US" sz="1100" dirty="0"/>
-          </a:p>
-        </p:txBody>
-      </p:sp>
-      <p:sp>
-        <p:nvSpPr>
-          <p:cNvPr id="14" name="Text 12"/>
-          <p:cNvSpPr txBox="1"/>
-          <p:nvPr/>
-        </p:nvSpPr>
-        <p:spPr>
-          <a:xfrm>
-            <a:off x="4389120" y="3858768"/>
-            <a:ext cx="6858000" cy="365760"/>
-          </a:xfrm>
-          <a:prstGeom prst="rect">
-            <a:avLst/>
-          </a:prstGeom>
-          <a:noFill/>
-          <a:ln/>
-        </p:spPr>
-        <p:txBody>
-          <a:bodyPr wrap="square" lIns="0" tIns="0" rIns="0" bIns="0" rtlCol="0" anchor="ctr"/>
-          <a:lstStyle/>
-          <a:p>
-            <a:pPr indent="0" marL="0">
-              <a:buNone/>
-            </a:pPr>
-            <a:r>
-              <a:rPr lang="en-US" sz="1250" dirty="0">
+              <a:rPr lang="en-US" sz="1300" dirty="0">
                 <a:solidFill>
                   <a:srgbClr val="1C7293"/>
                 </a:solidFill>
@@ -3340,7 +3334,7 @@
               </a:rPr>
               <a:t>Data Model Diagram, Deployment</a:t>
             </a:r>
-            <a:endParaRPr lang="en-US" sz="1250" dirty="0"/>
+            <a:endParaRPr lang="en-US" sz="1300" dirty="0"/>
           </a:p>
         </p:txBody>
       </p:sp>
@@ -3352,20 +3346,18 @@
         </p:nvSpPr>
         <p:spPr>
           <a:xfrm>
-            <a:off x="640080" y="4617720"/>
-            <a:ext cx="10881360" cy="868680"/>
-          </a:xfrm>
-          <a:prstGeom prst="roundRect">
-            <a:avLst>
-              <a:gd name="adj" fmla="val 6316"/>
-            </a:avLst>
+            <a:off x="640080" y="4480560"/>
+            <a:ext cx="365760" cy="365760"/>
+          </a:xfrm>
+          <a:prstGeom prst="ellipse">
+            <a:avLst/>
           </a:prstGeom>
           <a:solidFill>
-            <a:srgbClr val="F4F7F9"/>
+            <a:srgbClr val="1C7293"/>
           </a:solidFill>
           <a:ln w="12700">
             <a:solidFill>
-              <a:srgbClr val="E1E7EC"/>
+              <a:srgbClr val="333333"/>
             </a:solidFill>
             <a:prstDash val="solid"/>
           </a:ln>
@@ -3379,8 +3371,47 @@
         </p:nvSpPr>
         <p:spPr>
           <a:xfrm>
-            <a:off x="914400" y="4709160"/>
-            <a:ext cx="3291840" cy="365760"/>
+            <a:off x="640080" y="4480560"/>
+            <a:ext cx="365760" cy="365760"/>
+          </a:xfrm>
+          <a:prstGeom prst="rect">
+            <a:avLst/>
+          </a:prstGeom>
+          <a:noFill/>
+          <a:ln/>
+        </p:spPr>
+        <p:txBody>
+          <a:bodyPr wrap="square" lIns="0" tIns="0" rIns="0" bIns="0" rtlCol="0" anchor="ctr"/>
+          <a:lstStyle/>
+          <a:p>
+            <a:pPr algn="ctr" indent="0" marL="0">
+              <a:buNone/>
+            </a:pPr>
+            <a:r>
+              <a:rPr lang="en-US" sz="1400" b="1" dirty="0">
+                <a:solidFill>
+                  <a:srgbClr val="FFFFFF"/>
+                </a:solidFill>
+                <a:latin typeface="Calibri" pitchFamily="34" charset="0"/>
+                <a:ea typeface="Calibri" pitchFamily="34" charset="-122"/>
+                <a:cs typeface="Calibri" pitchFamily="34" charset="-120"/>
+              </a:rPr>
+              <a:t>4</a:t>
+            </a:r>
+            <a:endParaRPr lang="en-US" sz="1400" dirty="0"/>
+          </a:p>
+        </p:txBody>
+      </p:sp>
+      <p:sp>
+        <p:nvSpPr>
+          <p:cNvPr id="17" name="Text 15"/>
+          <p:cNvSpPr txBox="1"/>
+          <p:nvPr/>
+        </p:nvSpPr>
+        <p:spPr>
+          <a:xfrm>
+            <a:off x="1188720" y="4434840"/>
+            <a:ext cx="9966960" cy="365760"/>
           </a:xfrm>
           <a:prstGeom prst="rect">
             <a:avLst/>
@@ -3396,7 +3427,7 @@
               <a:buNone/>
             </a:pPr>
             <a:r>
-              <a:rPr lang="en-US" sz="1400" b="1" dirty="0">
+              <a:rPr lang="en-US" sz="1500" b="1" dirty="0">
                 <a:solidFill>
                   <a:srgbClr val="1B1F2A"/>
                 </a:solidFill>
@@ -3404,22 +3435,22 @@
                 <a:ea typeface="Calibri" pitchFamily="34" charset="-122"/>
                 <a:cs typeface="Calibri" pitchFamily="34" charset="-120"/>
               </a:rPr>
-              <a:t>เยี่ยมภพ ใบโพธิ์</a:t>
-            </a:r>
-            <a:endParaRPr lang="en-US" sz="1400" dirty="0"/>
-          </a:p>
-        </p:txBody>
-      </p:sp>
-      <p:sp>
-        <p:nvSpPr>
-          <p:cNvPr id="17" name="Text 15"/>
-          <p:cNvSpPr txBox="1"/>
-          <p:nvPr/>
-        </p:nvSpPr>
-        <p:spPr>
-          <a:xfrm>
-            <a:off x="914400" y="5074920"/>
-            <a:ext cx="3291840" cy="320040"/>
+              <a:t>เยี่ยมภพ ใบโพธิ์  (@yiampopbaipo)</a:t>
+            </a:r>
+            <a:endParaRPr lang="en-US" sz="1500" dirty="0"/>
+          </a:p>
+        </p:txBody>
+      </p:sp>
+      <p:sp>
+        <p:nvSpPr>
+          <p:cNvPr id="18" name="Text 16"/>
+          <p:cNvSpPr txBox="1"/>
+          <p:nvPr/>
+        </p:nvSpPr>
+        <p:spPr>
+          <a:xfrm>
+            <a:off x="1188720" y="4800600"/>
+            <a:ext cx="9966960" cy="365760"/>
           </a:xfrm>
           <a:prstGeom prst="rect">
             <a:avLst/>
@@ -3435,46 +3466,7 @@
               <a:buNone/>
             </a:pPr>
             <a:r>
-              <a:rPr lang="en-US" sz="1100" dirty="0">
-                <a:solidFill>
-                  <a:srgbClr val="5B6472"/>
-                </a:solidFill>
-                <a:latin typeface="Calibri" pitchFamily="34" charset="0"/>
-                <a:ea typeface="Calibri" pitchFamily="34" charset="-122"/>
-                <a:cs typeface="Calibri" pitchFamily="34" charset="-120"/>
-              </a:rPr>
-              <a:t>@yiampopbaipo</a:t>
-            </a:r>
-            <a:endParaRPr lang="en-US" sz="1100" dirty="0"/>
-          </a:p>
-        </p:txBody>
-      </p:sp>
-      <p:sp>
-        <p:nvSpPr>
-          <p:cNvPr id="18" name="Text 16"/>
-          <p:cNvSpPr txBox="1"/>
-          <p:nvPr/>
-        </p:nvSpPr>
-        <p:spPr>
-          <a:xfrm>
-            <a:off x="4389120" y="4864608"/>
-            <a:ext cx="6858000" cy="365760"/>
-          </a:xfrm>
-          <a:prstGeom prst="rect">
-            <a:avLst/>
-          </a:prstGeom>
-          <a:noFill/>
-          <a:ln/>
-        </p:spPr>
-        <p:txBody>
-          <a:bodyPr wrap="square" lIns="0" tIns="0" rIns="0" bIns="0" rtlCol="0" anchor="ctr"/>
-          <a:lstStyle/>
-          <a:p>
-            <a:pPr indent="0" marL="0">
-              <a:buNone/>
-            </a:pPr>
-            <a:r>
-              <a:rPr lang="en-US" sz="1250" dirty="0">
+              <a:rPr lang="en-US" sz="1300" dirty="0">
                 <a:solidFill>
                   <a:srgbClr val="1C7293"/>
                 </a:solidFill>
@@ -3484,7 +3476,7 @@
               </a:rPr>
               <a:t>Dashboard, Presentation</a:t>
             </a:r>
-            <a:endParaRPr lang="en-US" sz="1250" dirty="0"/>
+            <a:endParaRPr lang="en-US" sz="1300" dirty="0"/>
           </a:p>
         </p:txBody>
       </p:sp>

</xml_diff>

<commit_message>
Fix real cause of PowerPoint repair prompt: negative shape extents
The ER-diagram connector lines on slide 1 computed width/height as raw
coordinate differences, producing negative <a:ext cx/cy> values on
diagonal connectors (e.g. ORDER_ITEMS -> PRODUCTS, which goes upward).
ST_PositiveCoordinate must be non-negative, so PowerPoint's stricter
loader flagged the file for repair even though generic OOXML validators
passed it. Normalize connector() to min/abs + flipV, matching the
already-safe pattern used in the star schema diagram slide. Verified: no
negative cx/cy anywhere in the deck, and validate.py still passes clean.
</commit_message>
<xml_diff>
--- a/deliverables/Mini_Project_Olist_DW.pptx
+++ b/deliverables/Mini_Project_Olist_DW.pptx
@@ -4542,9 +4542,9 @@
           <p:nvPr/>
         </p:nvSpPr>
         <p:spPr>
-          <a:xfrm>
-            <a:off x="8001000" y="3543300"/>
-            <a:ext cx="457200" cy="-731520"/>
+          <a:xfrm flipV="1">
+            <a:off x="8001000" y="2811780"/>
+            <a:ext cx="457200" cy="731520"/>
           </a:xfrm>
           <a:prstGeom prst="line">
             <a:avLst/>

</xml_diff>